<commit_message>
docs: numbering fixes, soften Mod #4, drop doing-it-twice slide
  • Mod #3 (Mixed Tide) intro: feature request #3 → #4 (post-split).
  • Mod #4 (Rainy Season) intro: feature request #4 → #5.
  • Title slide notes: "three live demos" → "five live demos".
  • Mod #4 design slide: dropped the speculative "WaterAdditionService"
    type name in favour of "decomp, grep for AddWater/AddDepth, pick a
    seam if one exists" — won't get corrected by someone in the room
    who's actually modded Timberborn before. Speaker notes acknowledge
    the deliberate non-naming.
  • Removed _slide_doing_it_twice. The three gotchas it surfaced are
    already in the catalogue ahead. The headline "patch design held up
    under parallel branches" insight is preserved in the contamination-
    seam slide's speaker notes.

37 slides now. README time table updated.
</commit_message>
<xml_diff>
--- a/talk/timberborn-talk.pptx
+++ b/talk/timberborn-talk.pptx
@@ -42,7 +42,6 @@
     <p:sldId id="290" r:id="rId42"/>
     <p:sldId id="291" r:id="rId43"/>
     <p:sldId id="292" r:id="rId44"/>
-    <p:sldId id="293" r:id="rId45"/>
   </p:sldIdLst>
   <p:sldSz cx="12191695" cy="6858000" type="screen4x3"/>
   <p:notesSz cx="6858000" cy="9144000"/>
@@ -545,7 +544,7 @@
           <a:p/>
           <a:p>
             <a:r>
-              <a:t>Set expectations: technical walkthrough, three live demos, a future-work tease at the end, ~55 minutes content with Q&amp;A after.</a:t>
+              <a:t>Set expectations: technical walkthrough, five live demos interleaved, a future-work tease at the end, ~55 minutes content with Q&amp;A after.</a:t>
             </a:r>
           </a:p>
         </p:txBody>
@@ -2722,6 +2721,12 @@
               <a:t>Hat-tip to Mechanistry: contamination flows through the water-column simulation as a real fraction. No hardcoded 'if &gt; 0 emit bad water'. Our 30% setting produces actual 30%/70% mixed water that diffuses correctly.</a:t>
             </a:r>
           </a:p>
+          <a:p/>
+          <a:p>
+            <a:r>
+              <a:t>Headline insight on doing the second pass: the patch design from Flood Season held up. Every existing patch — UI helper substitution, sound player skip, label substitutions, art overrides — just needed ONE more conditional branch for Mixed Tide. No restructuring. The gotchas it did surface are in the catalogue ahead.</a:t>
+            </a:r>
+          </a:p>
         </p:txBody>
       </p:sp>
       <p:sp>
@@ -2896,13 +2901,13 @@
           <a:lstStyle/>
           <a:p>
             <a:r>
-              <a:t>The headline insight: the patch DESIGN from Flood Season held up. Mixed Tide didn't require restructuring anything — every existing patch just needed one more conditional branch.</a:t>
+              <a:t>If anyone takes a photo of one slide during the talk, it'll be this one. Land it slowly — these are the nine real landmines we hit and wrote down for next time.</a:t>
             </a:r>
           </a:p>
           <a:p/>
           <a:p>
             <a:r>
-              <a:t>The third gotcha is the architecturally interesting one: when we force-restore the weather in PostLoad, the entity-side components have already initialised with the wrong belief about what the current weather is. They need a wake-up signal — we subscribe to HazardousWeatherSelectedEvent guarded by IsHazardousWeather, which fires naturally during our PostLoad re-emit and stays quiet during vanilla cycle-start.</a:t>
+              <a:t>Each one started as a crash, a wrong-looking screenshot, or a confusing log line. The discipline that made the list useful: write it down the moment you've understood the cause, before the context evaporates.</a:t>
             </a:r>
           </a:p>
         </p:txBody>
@@ -2972,13 +2977,13 @@
           <a:lstStyle/>
           <a:p>
             <a:r>
-              <a:t>If anyone takes a photo of one slide during the talk, it'll be this one. Land it slowly — these are the nine real landmines we hit and wrote down for next time.</a:t>
+              <a:t>Closing tease. The mod we haven't built yet.</a:t>
             </a:r>
           </a:p>
           <a:p/>
           <a:p>
             <a:r>
-              <a:t>Each one started as a crash, a wrong-looking screenshot, or a confusing log line. The discipline that made the list useful: write it down the moment you've understood the cause, before the context evaporates.</a:t>
+              <a:t>Frame it as 'here's the next one — let me walk you through what I'd need to find to make it work. Note the workflow is the same as the other three: decompile, find the seam, choose the layer.'</a:t>
             </a:r>
           </a:p>
         </p:txBody>
@@ -3048,13 +3053,25 @@
           <a:lstStyle/>
           <a:p>
             <a:r>
-              <a:t>Closing tease. The mod we haven't built yet.</a:t>
+              <a:t>This is genuinely the next thing. Don't promise — the talk's already shipped three mods, the audience doesn't need a fourth.</a:t>
             </a:r>
           </a:p>
           <a:p/>
           <a:p>
             <a:r>
-              <a:t>Frame it as 'here's the next one — let me walk you through what I'd need to find to make it work. Note the workflow is the same as the other three: decompile, find the seam, choose the layer.'</a:t>
+              <a:t>Useful talking point: 'this is the workflow you'd use too. Decompile, grep for keywords matching the behaviour you want, find the seam (or discover there isn't one), pick the layer, start patching.'</a:t>
+            </a:r>
+          </a:p>
+          <a:p/>
+          <a:p>
+            <a:r>
+              <a:t>I haven't actually grepped yet, so I'm not naming specific types — promising 'WaterAdditionService' would invite a 'no, it's called X' from anyone who's modded Timberborn before.</a:t>
+            </a:r>
+          </a:p>
+          <a:p/>
+          <a:p>
+            <a:r>
+              <a:t>If anyone asks 'when will this be done?' — Jasper hasn't actually asked yet, this is me predicting. Don't commit to a timeline.</a:t>
             </a:r>
           </a:p>
         </p:txBody>
@@ -3080,88 +3097,6 @@
 </file>
 
 <file path=ppt/notesSlides/notesSlide37.xml><?xml version="1.0" encoding="utf-8"?>
-<p:notes xmlns:a="http://schemas.openxmlformats.org/drawingml/2006/main" xmlns:p="http://schemas.openxmlformats.org/presentationml/2006/main" xmlns:r="http://schemas.openxmlformats.org/officeDocument/2006/relationships">
-  <p:cSld>
-    <p:spTree>
-      <p:nvGrpSpPr>
-        <p:cNvPr id="1" name=""/>
-        <p:cNvGrpSpPr/>
-        <p:nvPr/>
-      </p:nvGrpSpPr>
-      <p:grpSpPr>
-        <a:xfrm>
-          <a:off x="0" y="0"/>
-          <a:ext cx="0" cy="0"/>
-          <a:chOff x="0" y="0"/>
-          <a:chExt cx="0" cy="0"/>
-        </a:xfrm>
-      </p:grpSpPr>
-      <p:sp>
-        <p:nvSpPr>
-          <p:cNvPr id="2" name="Slide Image Placeholder 1"/>
-          <p:cNvSpPr>
-            <a:spLocks noGrp="1"/>
-          </p:cNvSpPr>
-          <p:nvPr>
-            <p:ph type="sldImg" idx="2"/>
-          </p:nvPr>
-        </p:nvSpPr>
-        <p:spPr/>
-      </p:sp>
-      <p:sp>
-        <p:nvSpPr>
-          <p:cNvPr id="3" name="Notes Placeholder 2"/>
-          <p:cNvSpPr>
-            <a:spLocks noGrp="1"/>
-          </p:cNvSpPr>
-          <p:nvPr>
-            <p:ph type="body" idx="3" sz="quarter"/>
-          </p:nvPr>
-        </p:nvSpPr>
-        <p:spPr/>
-        <p:txBody>
-          <a:bodyPr/>
-          <a:lstStyle/>
-          <a:p>
-            <a:r>
-              <a:t>This is genuinely the next thing. Don't promise — the talk's already shipped three mods, the audience doesn't need a fourth.</a:t>
-            </a:r>
-          </a:p>
-          <a:p/>
-          <a:p>
-            <a:r>
-              <a:t>Useful talking point: 'this is the workflow you'd use too. Decompile, grep for keywords matching the behaviour you want, find the seam (or discover there isn't one), pick the layer, start patching.'</a:t>
-            </a:r>
-          </a:p>
-          <a:p/>
-          <a:p>
-            <a:r>
-              <a:t>If anyone asks 'when will this be done?' — Jasper hasn't actually asked yet, this is me predicting. Don't commit to a timeline.</a:t>
-            </a:r>
-          </a:p>
-        </p:txBody>
-      </p:sp>
-      <p:sp>
-        <p:nvSpPr>
-          <p:cNvPr id="4" name="Slide Number Placeholder 3"/>
-          <p:cNvSpPr>
-            <a:spLocks noGrp="1"/>
-          </p:cNvSpPr>
-          <p:nvPr>
-            <p:ph type="sldNum" idx="5" sz="quarter"/>
-          </p:nvPr>
-        </p:nvSpPr>
-        <p:spPr/>
-      </p:sp>
-    </p:spTree>
-  </p:cSld>
-  <p:clrMapOvr>
-    <a:masterClrMapping/>
-  </p:clrMapOvr>
-</p:notes>
-</file>
-
-<file path=ppt/notesSlides/notesSlide38.xml><?xml version="1.0" encoding="utf-8"?>
 <p:notes xmlns:a="http://schemas.openxmlformats.org/drawingml/2006/main" xmlns:p="http://schemas.openxmlformats.org/presentationml/2006/main" xmlns:r="http://schemas.openxmlformats.org/officeDocument/2006/relationships">
   <p:cSld>
     <p:spTree>
@@ -7325,7 +7260,7 @@
                 </a:solidFill>
                 <a:latin typeface="Calibri"/>
               </a:rPr>
-              <a:t>Mod #1: Quadruple Platform   ·   10 / 38</a:t>
+              <a:t>Mod #1: Quadruple Platform   ·   10 / 37</a:t>
             </a:r>
           </a:p>
         </p:txBody>
@@ -7772,7 +7707,7 @@
                 </a:solidFill>
                 <a:latin typeface="Calibri"/>
               </a:rPr>
-              <a:t>Mod #1: Quadruple Platform   ·   11 / 38</a:t>
+              <a:t>Mod #1: Quadruple Platform   ·   11 / 37</a:t>
             </a:r>
           </a:p>
         </p:txBody>
@@ -8243,7 +8178,7 @@
                 </a:solidFill>
                 <a:latin typeface="Calibri"/>
               </a:rPr>
-              <a:t>Mod #1: Quadruple Platform   ·   12 / 38</a:t>
+              <a:t>Mod #1: Quadruple Platform   ·   12 / 37</a:t>
             </a:r>
           </a:p>
         </p:txBody>
@@ -8477,7 +8412,7 @@
                 </a:solidFill>
                 <a:latin typeface="Calibri"/>
               </a:rPr>
-              <a:t>Mod #1: Quadruple Platform   ·   13 / 38</a:t>
+              <a:t>Mod #1: Quadruple Platform   ·   13 / 37</a:t>
             </a:r>
           </a:p>
         </p:txBody>
@@ -8608,7 +8543,7 @@
                 </a:solidFill>
                 <a:latin typeface="Calibri"/>
               </a:rPr>
-              <a:t>Mod #2: Flood Season — flow   ·   14 / 38</a:t>
+              <a:t>Mod #2: Flood Season — flow   ·   14 / 37</a:t>
             </a:r>
           </a:p>
         </p:txBody>
@@ -8947,7 +8882,7 @@
                 </a:solidFill>
                 <a:latin typeface="Calibri"/>
               </a:rPr>
-              <a:t>Mod #2: Flood Season — flow   ·   15 / 38</a:t>
+              <a:t>Mod #2: Flood Season — flow   ·   15 / 37</a:t>
             </a:r>
           </a:p>
         </p:txBody>
@@ -9310,7 +9245,7 @@
                 </a:solidFill>
                 <a:latin typeface="Calibri"/>
               </a:rPr>
-              <a:t>Mod #2: Flood Season — flow   ·   16 / 38</a:t>
+              <a:t>Mod #2: Flood Season — flow   ·   16 / 37</a:t>
             </a:r>
           </a:p>
         </p:txBody>
@@ -9685,7 +9620,7 @@
                 </a:solidFill>
                 <a:latin typeface="Calibri"/>
               </a:rPr>
-              <a:t>Mod #2: Flood Season — flow   ·   17 / 38</a:t>
+              <a:t>Mod #2: Flood Season — flow   ·   17 / 37</a:t>
             </a:r>
           </a:p>
         </p:txBody>
@@ -10108,7 +10043,7 @@
                 </a:solidFill>
                 <a:latin typeface="Calibri"/>
               </a:rPr>
-              <a:t>Mod #2: Flood Season — flow   ·   18 / 38</a:t>
+              <a:t>Mod #2: Flood Season — flow   ·   18 / 37</a:t>
             </a:r>
           </a:p>
         </p:txBody>
@@ -10342,7 +10277,7 @@
                 </a:solidFill>
                 <a:latin typeface="Calibri"/>
               </a:rPr>
-              <a:t>Mod #2: Flood Season — flow   ·   19 / 38</a:t>
+              <a:t>Mod #2: Flood Season — flow   ·   19 / 37</a:t>
             </a:r>
           </a:p>
         </p:txBody>
@@ -10837,7 +10772,7 @@
                 </a:solidFill>
                 <a:latin typeface="Calibri"/>
               </a:rPr>
-              <a:t>Opening   ·   2 / 38</a:t>
+              <a:t>Opening   ·   2 / 37</a:t>
             </a:r>
           </a:p>
         </p:txBody>
@@ -10968,7 +10903,7 @@
                 </a:solidFill>
                 <a:latin typeface="Calibri"/>
               </a:rPr>
-              <a:t>Mod #2: Flood Season — hazard   ·   20 / 38</a:t>
+              <a:t>Mod #2: Flood Season — hazard   ·   20 / 37</a:t>
             </a:r>
           </a:p>
         </p:txBody>
@@ -11295,7 +11230,7 @@
                 </a:solidFill>
                 <a:latin typeface="Calibri"/>
               </a:rPr>
-              <a:t>Mod #2: Flood Season — hazard   ·   21 / 38</a:t>
+              <a:t>Mod #2: Flood Season — hazard   ·   21 / 37</a:t>
             </a:r>
           </a:p>
         </p:txBody>
@@ -11561,7 +11496,7 @@
                 </a:solidFill>
                 <a:latin typeface="Calibri"/>
               </a:rPr>
-              <a:t>Mod #2: Flood Season — hazard   ·   22 / 38</a:t>
+              <a:t>Mod #2: Flood Season — hazard   ·   22 / 37</a:t>
             </a:r>
           </a:p>
         </p:txBody>
@@ -11936,7 +11871,7 @@
                 </a:solidFill>
                 <a:latin typeface="Calibri"/>
               </a:rPr>
-              <a:t>Mod #2: Flood Season — hazard   ·   23 / 38</a:t>
+              <a:t>Mod #2: Flood Season — hazard   ·   23 / 37</a:t>
             </a:r>
           </a:p>
         </p:txBody>
@@ -12170,7 +12105,7 @@
                 </a:solidFill>
                 <a:latin typeface="Calibri"/>
               </a:rPr>
-              <a:t>Mod #2: Flood Season — hazard   ·   24 / 38</a:t>
+              <a:t>Mod #2: Flood Season — hazard   ·   24 / 37</a:t>
             </a:r>
           </a:p>
         </p:txBody>
@@ -12420,7 +12355,7 @@
                 </a:solidFill>
                 <a:latin typeface="Calibri"/>
               </a:rPr>
-              <a:t>The cascade   ·   25 / 38</a:t>
+              <a:t>The cascade   ·   25 / 37</a:t>
             </a:r>
           </a:p>
         </p:txBody>
@@ -12807,7 +12742,7 @@
                 </a:solidFill>
                 <a:latin typeface="Calibri"/>
               </a:rPr>
-              <a:t>The cascade   ·   26 / 38</a:t>
+              <a:t>The cascade   ·   26 / 37</a:t>
             </a:r>
           </a:p>
         </p:txBody>
@@ -13242,7 +13177,7 @@
                 </a:solidFill>
                 <a:latin typeface="Calibri"/>
               </a:rPr>
-              <a:t>The cascade   ·   27 / 38</a:t>
+              <a:t>The cascade   ·   27 / 37</a:t>
             </a:r>
           </a:p>
         </p:txBody>
@@ -13508,7 +13443,7 @@
                 </a:solidFill>
                 <a:latin typeface="Calibri"/>
               </a:rPr>
-              <a:t>The cascade   ·   28 / 38</a:t>
+              <a:t>The cascade   ·   28 / 37</a:t>
             </a:r>
           </a:p>
         </p:txBody>
@@ -14003,7 +13938,7 @@
                 </a:solidFill>
                 <a:latin typeface="Calibri"/>
               </a:rPr>
-              <a:t>Save / load   ·   29 / 38</a:t>
+              <a:t>Save / load   ·   29 / 37</a:t>
             </a:r>
           </a:p>
         </p:txBody>
@@ -14301,7 +14236,7 @@
                 </a:solidFill>
                 <a:latin typeface="Calibri"/>
               </a:rPr>
-              <a:t>Opening   ·   3 / 38</a:t>
+              <a:t>Opening   ·   3 / 37</a:t>
             </a:r>
           </a:p>
         </p:txBody>
@@ -14583,7 +14518,7 @@
                 </a:solidFill>
                 <a:latin typeface="Calibri"/>
               </a:rPr>
-              <a:t>Save / load   ·   30 / 38</a:t>
+              <a:t>Save / load   ·   30 / 37</a:t>
             </a:r>
           </a:p>
         </p:txBody>
@@ -14679,7 +14614,7 @@
                 </a:solidFill>
                 <a:latin typeface="Calibri"/>
               </a:rPr>
-              <a:t>— Jasper, feature request #3</a:t>
+              <a:t>— Jasper, feature request #4</a:t>
             </a:r>
           </a:p>
         </p:txBody>
@@ -14714,7 +14649,7 @@
                 </a:solidFill>
                 <a:latin typeface="Calibri"/>
               </a:rPr>
-              <a:t>Mod #3: Mixed Tide   ·   31 / 38</a:t>
+              <a:t>Mod #3: Mixed Tide   ·   31 / 37</a:t>
             </a:r>
           </a:p>
         </p:txBody>
@@ -15149,7 +15084,7 @@
                 </a:solidFill>
                 <a:latin typeface="Calibri"/>
               </a:rPr>
-              <a:t>Mod #3: Mixed Tide   ·   32 / 38</a:t>
+              <a:t>Mod #3: Mixed Tide   ·   32 / 37</a:t>
             </a:r>
           </a:p>
         </p:txBody>
@@ -15383,7 +15318,7 @@
                 </a:solidFill>
                 <a:latin typeface="Calibri"/>
               </a:rPr>
-              <a:t>Mod #3: Mixed Tide   ·   33 / 38</a:t>
+              <a:t>Mod #3: Mixed Tide   ·   33 / 37</a:t>
             </a:r>
           </a:p>
         </p:txBody>
@@ -15444,7 +15379,7 @@
                 </a:solidFill>
                 <a:latin typeface="Calibri"/>
               </a:rPr>
-              <a:t>Doing it twice — what the second pass revealed</a:t>
+              <a:t>Gotchas — nine landmines, documented</a:t>
             </a:r>
           </a:p>
         </p:txBody>
@@ -15518,55 +15453,7 @@
                 </a:solidFill>
                 <a:latin typeface="Calibri"/>
               </a:rPr>
-              <a:t>•  Every patch from the cascade needed ONE parallel branch for Mixed Tide.</a:t>
-            </a:r>
-          </a:p>
-          <a:p>
-            <a:pPr algn="l" lvl="1">
-              <a:spcAft>
-                <a:spcPts val="800"/>
-              </a:spcAft>
-            </a:pPr>
-            <a:r>
-              <a:rPr sz="1800">
-                <a:solidFill>
-                  <a:srgbClr val="556070"/>
-                </a:solidFill>
-                <a:latin typeface="Calibri"/>
-              </a:rPr>
-              <a:t>    –  WeatherUIHelperPatch: drought spec for flood, badtide spec for mixed.</a:t>
-            </a:r>
-          </a:p>
-          <a:p>
-            <a:pPr algn="l" lvl="1">
-              <a:spcAft>
-                <a:spcPts val="800"/>
-              </a:spcAft>
-            </a:pPr>
-            <a:r>
-              <a:rPr sz="1800">
-                <a:solidFill>
-                  <a:srgbClr val="556070"/>
-                </a:solidFill>
-                <a:latin typeface="Calibri"/>
-              </a:rPr>
-              <a:t>    –  UIHelperLabelsPatch: 5 × postfix get a MixedTide branch.</a:t>
-            </a:r>
-          </a:p>
-          <a:p>
-            <a:pPr algn="l" lvl="1">
-              <a:spcAft>
-                <a:spcPts val="800"/>
-              </a:spcAft>
-            </a:pPr>
-            <a:r>
-              <a:rPr sz="1800">
-                <a:solidFill>
-                  <a:srgbClr val="556070"/>
-                </a:solidFill>
-                <a:latin typeface="Calibri"/>
-              </a:rPr>
-              <a:t>    –  SoundPlayerPatch, NotificationBackgroundPatch, … same shape.</a:t>
+              <a:t>•  1. bin/obj outside the mod folder (absolute path, not relative)</a:t>
             </a:r>
           </a:p>
           <a:p>
@@ -15582,55 +15469,119 @@
                 </a:solidFill>
                 <a:latin typeface="Calibri"/>
               </a:rPr>
-              <a:t>•  Three new gotchas surfaced along the way:</a:t>
-            </a:r>
-          </a:p>
-          <a:p>
-            <a:pPr algn="l" lvl="1">
+              <a:t>•  2. Harmony field-injection needs FOUR underscores for vanilla underscored fields</a:t>
+            </a:r>
+          </a:p>
+          <a:p>
+            <a:pPr algn="l">
               <a:spcAft>
                 <a:spcPts val="800"/>
               </a:spcAft>
             </a:pPr>
             <a:r>
-              <a:rPr sz="1800">
-                <a:solidFill>
-                  <a:srgbClr val="556070"/>
-                </a:solidFill>
-                <a:latin typeface="Calibri"/>
-              </a:rPr>
-              <a:t>    –  `TemplateModule.AddDecorator` needs a paired `Bind&lt;T&gt;().AsTransient()`.</a:t>
-            </a:r>
-          </a:p>
-          <a:p>
-            <a:pPr algn="l" lvl="1">
+              <a:rPr sz="2200">
+                <a:solidFill>
+                  <a:srgbClr val="101824"/>
+                </a:solidFill>
+                <a:latin typeface="Calibri"/>
+              </a:rPr>
+              <a:t>•  3. Bindito AsSingleton() is lazy without a tagged interface (ILoadableSingleton)</a:t>
+            </a:r>
+          </a:p>
+          <a:p>
+            <a:pPr algn="l">
               <a:spcAft>
                 <a:spcPts val="800"/>
               </a:spcAft>
             </a:pPr>
             <a:r>
-              <a:rPr sz="1800">
-                <a:solidFill>
-                  <a:srgbClr val="556070"/>
-                </a:solidFill>
-                <a:latin typeface="Calibri"/>
-              </a:rPr>
-              <a:t>    –  `IObjectLoader.Get` throws on missing keys — use `loader.Has()` to guard.</a:t>
-            </a:r>
-          </a:p>
-          <a:p>
-            <a:pPr algn="l" lvl="1">
+              <a:rPr sz="2200">
+                <a:solidFill>
+                  <a:srgbClr val="101824"/>
+                </a:solidFill>
+                <a:latin typeface="Calibri"/>
+              </a:rPr>
+              <a:t>•  4. Vanilla type-checks throw on unknown IHazardousWeather (UI helper, sound, fog)</a:t>
+            </a:r>
+          </a:p>
+          <a:p>
+            <a:pPr algn="l">
               <a:spcAft>
                 <a:spcPts val="800"/>
               </a:spcAft>
             </a:pPr>
             <a:r>
-              <a:rPr sz="1800">
-                <a:solidFill>
-                  <a:srgbClr val="556070"/>
-                </a:solidFill>
-                <a:latin typeface="Calibri"/>
-              </a:rPr>
-              <a:t>    –  Entity controllers don't auto-wake on save-restore (PostLoad timing).</a:t>
+              <a:rPr sz="2200">
+                <a:solidFill>
+                  <a:srgbClr val="101824"/>
+                </a:solidFill>
+                <a:latin typeface="Calibri"/>
+              </a:rPr>
+              <a:t>•  5. Id-keyed lookups are spoofed via FloodWeather.Id = "DroughtWeather"</a:t>
+            </a:r>
+          </a:p>
+          <a:p>
+            <a:pPr algn="l">
+              <a:spcAft>
+                <a:spcPts val="800"/>
+              </a:spcAft>
+            </a:pPr>
+            <a:r>
+              <a:rPr sz="2200">
+                <a:solidFill>
+                  <a:srgbClr val="101824"/>
+                </a:solidFill>
+                <a:latin typeface="Calibri"/>
+              </a:rPr>
+              <a:t>•  6. Cycle weather is decided at cycle START — settings changes never retro-apply</a:t>
+            </a:r>
+          </a:p>
+          <a:p>
+            <a:pPr algn="l">
+              <a:spcAft>
+                <a:spcPts val="800"/>
+              </a:spcAft>
+            </a:pPr>
+            <a:r>
+              <a:rPr sz="2200">
+                <a:solidFill>
+                  <a:srgbClr val="101824"/>
+                </a:solidFill>
+                <a:latin typeface="Calibri"/>
+              </a:rPr>
+              <a:t>•  7. TemplateModule.AddDecorator needs paired Bind&lt;T&gt;().AsTransient()</a:t>
+            </a:r>
+          </a:p>
+          <a:p>
+            <a:pPr algn="l">
+              <a:spcAft>
+                <a:spcPts val="800"/>
+              </a:spcAft>
+            </a:pPr>
+            <a:r>
+              <a:rPr sz="2200">
+                <a:solidFill>
+                  <a:srgbClr val="101824"/>
+                </a:solidFill>
+                <a:latin typeface="Calibri"/>
+              </a:rPr>
+              <a:t>•  8. IObjectLoader.Get(PropertyKey&lt;T&gt;) throws on missing keys — use Has()</a:t>
+            </a:r>
+          </a:p>
+          <a:p>
+            <a:pPr algn="l">
+              <a:spcAft>
+                <a:spcPts val="800"/>
+              </a:spcAft>
+            </a:pPr>
+            <a:r>
+              <a:rPr sz="2200">
+                <a:solidFill>
+                  <a:srgbClr val="101824"/>
+                </a:solidFill>
+                <a:latin typeface="Calibri"/>
+              </a:rPr>
+              <a:t>•  9. Custom weathers don't auto-fire entity controllers on save-restore</a:t>
             </a:r>
           </a:p>
         </p:txBody>
@@ -15665,7 +15616,7 @@
                 </a:solidFill>
                 <a:latin typeface="Calibri"/>
               </a:rPr>
-              <a:t>Mod #3: Mixed Tide   ·   34 / 38</a:t>
+              <a:t>Gotchas &amp; workflow   ·   34 / 37</a:t>
             </a:r>
           </a:p>
         </p:txBody>
@@ -15679,6 +15630,137 @@
 </file>
 
 <file path=ppt/slides/slide35.xml><?xml version="1.0" encoding="utf-8"?>
+<p:sld xmlns:a="http://schemas.openxmlformats.org/drawingml/2006/main" xmlns:p="http://schemas.openxmlformats.org/presentationml/2006/main" xmlns:r="http://schemas.openxmlformats.org/officeDocument/2006/relationships">
+  <p:cSld>
+    <p:bg>
+      <p:bgPr>
+        <a:solidFill>
+          <a:srgbClr val="0A203A"/>
+        </a:solidFill>
+        <a:effectLst/>
+      </p:bgPr>
+    </p:bg>
+    <p:spTree>
+      <p:nvGrpSpPr>
+        <p:cNvPr id="1" name=""/>
+        <p:cNvGrpSpPr/>
+        <p:nvPr/>
+      </p:nvGrpSpPr>
+      <p:grpSpPr/>
+      <p:sp>
+        <p:nvSpPr>
+          <p:cNvPr id="2" name="TextBox 1"/>
+          <p:cNvSpPr txBox="1"/>
+          <p:nvPr/>
+        </p:nvSpPr>
+        <p:spPr>
+          <a:xfrm>
+            <a:off x="548640" y="1828800"/>
+            <a:ext cx="11094415" cy="2286000"/>
+          </a:xfrm>
+          <a:prstGeom prst="rect">
+            <a:avLst/>
+          </a:prstGeom>
+          <a:noFill/>
+        </p:spPr>
+        <p:txBody>
+          <a:bodyPr wrap="square" anchor="ctr">
+            <a:spAutoFit/>
+          </a:bodyPr>
+          <a:lstStyle/>
+          <a:p>
+            <a:pPr algn="ctr"/>
+            <a:r>
+              <a:rPr sz="4000" b="0">
+                <a:solidFill>
+                  <a:srgbClr val="F4F7FB"/>
+                </a:solidFill>
+                <a:latin typeface="Calibri Light"/>
+              </a:rPr>
+              <a:t>“What if water fell from the sky and made the map wet?”</a:t>
+            </a:r>
+          </a:p>
+        </p:txBody>
+      </p:sp>
+      <p:sp>
+        <p:nvSpPr>
+          <p:cNvPr id="3" name="TextBox 2"/>
+          <p:cNvSpPr txBox="1"/>
+          <p:nvPr/>
+        </p:nvSpPr>
+        <p:spPr>
+          <a:xfrm>
+            <a:off x="548640" y="4297680"/>
+            <a:ext cx="11094415" cy="731520"/>
+          </a:xfrm>
+          <a:prstGeom prst="rect">
+            <a:avLst/>
+          </a:prstGeom>
+          <a:noFill/>
+        </p:spPr>
+        <p:txBody>
+          <a:bodyPr wrap="square" anchor="ctr">
+            <a:spAutoFit/>
+          </a:bodyPr>
+          <a:lstStyle/>
+          <a:p>
+            <a:pPr algn="ctr"/>
+            <a:r>
+              <a:rPr sz="2200" b="0">
+                <a:solidFill>
+                  <a:srgbClr val="AADCF0"/>
+                </a:solidFill>
+                <a:latin typeface="Calibri"/>
+              </a:rPr>
+              <a:t>— Jasper, feature request #5 (pending)</a:t>
+            </a:r>
+          </a:p>
+        </p:txBody>
+      </p:sp>
+      <p:sp>
+        <p:nvSpPr>
+          <p:cNvPr id="4" name="TextBox 3"/>
+          <p:cNvSpPr txBox="1"/>
+          <p:nvPr/>
+        </p:nvSpPr>
+        <p:spPr>
+          <a:xfrm>
+            <a:off x="548640" y="6492240"/>
+            <a:ext cx="11094415" cy="320040"/>
+          </a:xfrm>
+          <a:prstGeom prst="rect">
+            <a:avLst/>
+          </a:prstGeom>
+          <a:noFill/>
+        </p:spPr>
+        <p:txBody>
+          <a:bodyPr wrap="square" anchor="t">
+            <a:spAutoFit/>
+          </a:bodyPr>
+          <a:lstStyle/>
+          <a:p>
+            <a:pPr algn="r"/>
+            <a:r>
+              <a:rPr sz="1000" b="0">
+                <a:solidFill>
+                  <a:srgbClr val="556070"/>
+                </a:solidFill>
+                <a:latin typeface="Calibri"/>
+              </a:rPr>
+              <a:t>Mod #4: Rainy Season (future)   ·   35 / 37</a:t>
+            </a:r>
+          </a:p>
+        </p:txBody>
+      </p:sp>
+    </p:spTree>
+  </p:cSld>
+  <p:clrMapOvr>
+    <a:masterClrMapping/>
+  </p:clrMapOvr>
+</p:sld>
+</file>
+
+<file path=ppt/slides/slide36.xml><?xml version="1.0" encoding="utf-8"?>
 <p:sld xmlns:a="http://schemas.openxmlformats.org/drawingml/2006/main" xmlns:p="http://schemas.openxmlformats.org/presentationml/2006/main" xmlns:r="http://schemas.openxmlformats.org/officeDocument/2006/relationships">
   <p:cSld>
     <p:bg>
@@ -15726,7 +15808,7 @@
                 </a:solidFill>
                 <a:latin typeface="Calibri"/>
               </a:rPr>
-              <a:t>Gotchas — nine landmines, documented</a:t>
+              <a:t>Mod #4 design sketch — where would we hook?</a:t>
             </a:r>
           </a:p>
         </p:txBody>
@@ -15800,7 +15882,7 @@
                 </a:solidFill>
                 <a:latin typeface="Calibri"/>
               </a:rPr>
-              <a:t>•  1. bin/obj outside the mod folder (absolute path, not relative)</a:t>
+              <a:t>•  Goal: water visibly falls from the sky and the map's surface gets wet.</a:t>
             </a:r>
           </a:p>
           <a:p>
@@ -15816,7 +15898,87 @@
                 </a:solidFill>
                 <a:latin typeface="Calibri"/>
               </a:rPr>
-              <a:t>•  2. Harmony field-injection needs FOUR underscores for vanilla underscored fields</a:t>
+              <a:t>•  Two components: a new IHazardousWeather (familiar) + a way to add water to map tiles.</a:t>
+            </a:r>
+          </a:p>
+          <a:p>
+            <a:pPr algn="l" lvl="1">
+              <a:spcAft>
+                <a:spcPts val="800"/>
+              </a:spcAft>
+            </a:pPr>
+            <a:r>
+              <a:rPr sz="1800">
+                <a:solidFill>
+                  <a:srgbClr val="556070"/>
+                </a:solidFill>
+                <a:latin typeface="Calibri"/>
+              </a:rPr>
+              <a:t>    –  Hazard plumbing: copy the FloodWeather pattern. Spoof Id, parallel branches in patches.</a:t>
+            </a:r>
+          </a:p>
+          <a:p>
+            <a:pPr algn="l" lvl="1">
+              <a:spcAft>
+                <a:spcPts val="800"/>
+              </a:spcAft>
+            </a:pPr>
+            <a:r>
+              <a:rPr sz="1800">
+                <a:solidFill>
+                  <a:srgbClr val="556070"/>
+                </a:solidFill>
+                <a:latin typeface="Calibri"/>
+              </a:rPr>
+              <a:t>    –  Water-adding mechanic: needs investigation. The workflow is the bit that's certain:</a:t>
+            </a:r>
+          </a:p>
+          <a:p>
+            <a:pPr algn="l" lvl="2">
+              <a:spcAft>
+                <a:spcPts val="800"/>
+              </a:spcAft>
+            </a:pPr>
+            <a:r>
+              <a:rPr sz="1800">
+                <a:solidFill>
+                  <a:srgbClr val="556070"/>
+                </a:solidFill>
+                <a:latin typeface="Calibri"/>
+              </a:rPr>
+              <a:t>        –  Decomp the WaterSystem DLL, grep for AddWater / AddDepth / column-mutation calls.</a:t>
+            </a:r>
+          </a:p>
+          <a:p>
+            <a:pPr algn="l" lvl="2">
+              <a:spcAft>
+                <a:spcPts val="800"/>
+              </a:spcAft>
+            </a:pPr>
+            <a:r>
+              <a:rPr sz="1800">
+                <a:solidFill>
+                  <a:srgbClr val="556070"/>
+                </a:solidFill>
+                <a:latin typeface="Calibri"/>
+              </a:rPr>
+              <a:t>        –  Pick a seam if one exists, otherwise plan a per-tile Harmony postfix.</a:t>
+            </a:r>
+          </a:p>
+          <a:p>
+            <a:pPr algn="l" lvl="2">
+              <a:spcAft>
+                <a:spcPts val="800"/>
+              </a:spcAft>
+            </a:pPr>
+            <a:r>
+              <a:rPr sz="1800">
+                <a:solidFill>
+                  <a:srgbClr val="556070"/>
+                </a:solidFill>
+                <a:latin typeface="Calibri"/>
+              </a:rPr>
+              <a:t>        –  Particle / visual layer: probably orthogonal. Game already has a rain shader for badtide.</a:t>
             </a:r>
           </a:p>
           <a:p>
@@ -15832,103 +15994,7 @@
                 </a:solidFill>
                 <a:latin typeface="Calibri"/>
               </a:rPr>
-              <a:t>•  3. Bindito AsSingleton() is lazy without a tagged interface (ILoadableSingleton)</a:t>
-            </a:r>
-          </a:p>
-          <a:p>
-            <a:pPr algn="l">
-              <a:spcAft>
-                <a:spcPts val="800"/>
-              </a:spcAft>
-            </a:pPr>
-            <a:r>
-              <a:rPr sz="2200">
-                <a:solidFill>
-                  <a:srgbClr val="101824"/>
-                </a:solidFill>
-                <a:latin typeface="Calibri"/>
-              </a:rPr>
-              <a:t>•  4. Vanilla type-checks throw on unknown IHazardousWeather (UI helper, sound, fog)</a:t>
-            </a:r>
-          </a:p>
-          <a:p>
-            <a:pPr algn="l">
-              <a:spcAft>
-                <a:spcPts val="800"/>
-              </a:spcAft>
-            </a:pPr>
-            <a:r>
-              <a:rPr sz="2200">
-                <a:solidFill>
-                  <a:srgbClr val="101824"/>
-                </a:solidFill>
-                <a:latin typeface="Calibri"/>
-              </a:rPr>
-              <a:t>•  5. Id-keyed lookups are spoofed via FloodWeather.Id = "DroughtWeather"</a:t>
-            </a:r>
-          </a:p>
-          <a:p>
-            <a:pPr algn="l">
-              <a:spcAft>
-                <a:spcPts val="800"/>
-              </a:spcAft>
-            </a:pPr>
-            <a:r>
-              <a:rPr sz="2200">
-                <a:solidFill>
-                  <a:srgbClr val="101824"/>
-                </a:solidFill>
-                <a:latin typeface="Calibri"/>
-              </a:rPr>
-              <a:t>•  6. Cycle weather is decided at cycle START — settings changes never retro-apply</a:t>
-            </a:r>
-          </a:p>
-          <a:p>
-            <a:pPr algn="l">
-              <a:spcAft>
-                <a:spcPts val="800"/>
-              </a:spcAft>
-            </a:pPr>
-            <a:r>
-              <a:rPr sz="2200">
-                <a:solidFill>
-                  <a:srgbClr val="101824"/>
-                </a:solidFill>
-                <a:latin typeface="Calibri"/>
-              </a:rPr>
-              <a:t>•  7. TemplateModule.AddDecorator needs paired Bind&lt;T&gt;().AsTransient()</a:t>
-            </a:r>
-          </a:p>
-          <a:p>
-            <a:pPr algn="l">
-              <a:spcAft>
-                <a:spcPts val="800"/>
-              </a:spcAft>
-            </a:pPr>
-            <a:r>
-              <a:rPr sz="2200">
-                <a:solidFill>
-                  <a:srgbClr val="101824"/>
-                </a:solidFill>
-                <a:latin typeface="Calibri"/>
-              </a:rPr>
-              <a:t>•  8. IObjectLoader.Get(PropertyKey&lt;T&gt;) throws on missing keys — use Has()</a:t>
-            </a:r>
-          </a:p>
-          <a:p>
-            <a:pPr algn="l">
-              <a:spcAft>
-                <a:spcPts val="800"/>
-              </a:spcAft>
-            </a:pPr>
-            <a:r>
-              <a:rPr sz="2200">
-                <a:solidFill>
-                  <a:srgbClr val="101824"/>
-                </a:solidFill>
-                <a:latin typeface="Calibri"/>
-              </a:rPr>
-              <a:t>•  9. Custom weathers don't auto-fire entity controllers on save-restore</a:t>
+              <a:t>•  Risk: if water-adding isn't exposed, we're back in Harmony-cascade territory.</a:t>
             </a:r>
           </a:p>
         </p:txBody>
@@ -15963,138 +16029,7 @@
                 </a:solidFill>
                 <a:latin typeface="Calibri"/>
               </a:rPr>
-              <a:t>Gotchas &amp; workflow   ·   35 / 38</a:t>
-            </a:r>
-          </a:p>
-        </p:txBody>
-      </p:sp>
-    </p:spTree>
-  </p:cSld>
-  <p:clrMapOvr>
-    <a:masterClrMapping/>
-  </p:clrMapOvr>
-</p:sld>
-</file>
-
-<file path=ppt/slides/slide36.xml><?xml version="1.0" encoding="utf-8"?>
-<p:sld xmlns:a="http://schemas.openxmlformats.org/drawingml/2006/main" xmlns:p="http://schemas.openxmlformats.org/presentationml/2006/main" xmlns:r="http://schemas.openxmlformats.org/officeDocument/2006/relationships">
-  <p:cSld>
-    <p:bg>
-      <p:bgPr>
-        <a:solidFill>
-          <a:srgbClr val="0A203A"/>
-        </a:solidFill>
-        <a:effectLst/>
-      </p:bgPr>
-    </p:bg>
-    <p:spTree>
-      <p:nvGrpSpPr>
-        <p:cNvPr id="1" name=""/>
-        <p:cNvGrpSpPr/>
-        <p:nvPr/>
-      </p:nvGrpSpPr>
-      <p:grpSpPr/>
-      <p:sp>
-        <p:nvSpPr>
-          <p:cNvPr id="2" name="TextBox 1"/>
-          <p:cNvSpPr txBox="1"/>
-          <p:nvPr/>
-        </p:nvSpPr>
-        <p:spPr>
-          <a:xfrm>
-            <a:off x="548640" y="1828800"/>
-            <a:ext cx="11094415" cy="2286000"/>
-          </a:xfrm>
-          <a:prstGeom prst="rect">
-            <a:avLst/>
-          </a:prstGeom>
-          <a:noFill/>
-        </p:spPr>
-        <p:txBody>
-          <a:bodyPr wrap="square" anchor="ctr">
-            <a:spAutoFit/>
-          </a:bodyPr>
-          <a:lstStyle/>
-          <a:p>
-            <a:pPr algn="ctr"/>
-            <a:r>
-              <a:rPr sz="4000" b="0">
-                <a:solidFill>
-                  <a:srgbClr val="F4F7FB"/>
-                </a:solidFill>
-                <a:latin typeface="Calibri Light"/>
-              </a:rPr>
-              <a:t>“What if water fell from the sky and made the map wet?”</a:t>
-            </a:r>
-          </a:p>
-        </p:txBody>
-      </p:sp>
-      <p:sp>
-        <p:nvSpPr>
-          <p:cNvPr id="3" name="TextBox 2"/>
-          <p:cNvSpPr txBox="1"/>
-          <p:nvPr/>
-        </p:nvSpPr>
-        <p:spPr>
-          <a:xfrm>
-            <a:off x="548640" y="4297680"/>
-            <a:ext cx="11094415" cy="731520"/>
-          </a:xfrm>
-          <a:prstGeom prst="rect">
-            <a:avLst/>
-          </a:prstGeom>
-          <a:noFill/>
-        </p:spPr>
-        <p:txBody>
-          <a:bodyPr wrap="square" anchor="ctr">
-            <a:spAutoFit/>
-          </a:bodyPr>
-          <a:lstStyle/>
-          <a:p>
-            <a:pPr algn="ctr"/>
-            <a:r>
-              <a:rPr sz="2200" b="0">
-                <a:solidFill>
-                  <a:srgbClr val="AADCF0"/>
-                </a:solidFill>
-                <a:latin typeface="Calibri"/>
-              </a:rPr>
-              <a:t>— Jasper, feature request #4 (pending)</a:t>
-            </a:r>
-          </a:p>
-        </p:txBody>
-      </p:sp>
-      <p:sp>
-        <p:nvSpPr>
-          <p:cNvPr id="4" name="TextBox 3"/>
-          <p:cNvSpPr txBox="1"/>
-          <p:nvPr/>
-        </p:nvSpPr>
-        <p:spPr>
-          <a:xfrm>
-            <a:off x="548640" y="6492240"/>
-            <a:ext cx="11094415" cy="320040"/>
-          </a:xfrm>
-          <a:prstGeom prst="rect">
-            <a:avLst/>
-          </a:prstGeom>
-          <a:noFill/>
-        </p:spPr>
-        <p:txBody>
-          <a:bodyPr wrap="square" anchor="t">
-            <a:spAutoFit/>
-          </a:bodyPr>
-          <a:lstStyle/>
-          <a:p>
-            <a:pPr algn="r"/>
-            <a:r>
-              <a:rPr sz="1000" b="0">
-                <a:solidFill>
-                  <a:srgbClr val="556070"/>
-                </a:solidFill>
-                <a:latin typeface="Calibri"/>
-              </a:rPr>
-              <a:t>Mod #4: Rainy Season (future)   ·   36 / 38</a:t>
+              <a:t>Mod #4: Rainy Season (future)   ·   36 / 37</a:t>
             </a:r>
           </a:p>
         </p:txBody>
@@ -16108,288 +16043,6 @@
 </file>
 
 <file path=ppt/slides/slide37.xml><?xml version="1.0" encoding="utf-8"?>
-<p:sld xmlns:a="http://schemas.openxmlformats.org/drawingml/2006/main" xmlns:p="http://schemas.openxmlformats.org/presentationml/2006/main" xmlns:r="http://schemas.openxmlformats.org/officeDocument/2006/relationships">
-  <p:cSld>
-    <p:bg>
-      <p:bgPr>
-        <a:solidFill>
-          <a:srgbClr val="F4F7FB"/>
-        </a:solidFill>
-        <a:effectLst/>
-      </p:bgPr>
-    </p:bg>
-    <p:spTree>
-      <p:nvGrpSpPr>
-        <p:cNvPr id="1" name=""/>
-        <p:cNvGrpSpPr/>
-        <p:nvPr/>
-      </p:nvGrpSpPr>
-      <p:grpSpPr/>
-      <p:sp>
-        <p:nvSpPr>
-          <p:cNvPr id="2" name="TextBox 1"/>
-          <p:cNvSpPr txBox="1"/>
-          <p:nvPr/>
-        </p:nvSpPr>
-        <p:spPr>
-          <a:xfrm>
-            <a:off x="548640" y="320040"/>
-            <a:ext cx="11094415" cy="822960"/>
-          </a:xfrm>
-          <a:prstGeom prst="rect">
-            <a:avLst/>
-          </a:prstGeom>
-          <a:noFill/>
-        </p:spPr>
-        <p:txBody>
-          <a:bodyPr wrap="square" anchor="ctr">
-            <a:spAutoFit/>
-          </a:bodyPr>
-          <a:lstStyle/>
-          <a:p>
-            <a:pPr algn="l"/>
-            <a:r>
-              <a:rPr sz="3200" b="1">
-                <a:solidFill>
-                  <a:srgbClr val="0A203A"/>
-                </a:solidFill>
-                <a:latin typeface="Calibri"/>
-              </a:rPr>
-              <a:t>Mod #4 design sketch — where would we hook?</a:t>
-            </a:r>
-          </a:p>
-        </p:txBody>
-      </p:sp>
-      <p:cxnSp>
-        <p:nvCxnSpPr>
-          <p:cNvPr id="3" name="Connector 2"/>
-          <p:cNvCxnSpPr/>
-          <p:nvPr/>
-        </p:nvCxnSpPr>
-        <p:spPr>
-          <a:xfrm>
-            <a:off x="548640" y="1143000"/>
-            <a:ext cx="11094415" cy="0"/>
-          </a:xfrm>
-          <a:prstGeom prst="line">
-            <a:avLst/>
-          </a:prstGeom>
-          <a:ln w="19050">
-            <a:solidFill>
-              <a:srgbClr val="2C74AF"/>
-            </a:solidFill>
-          </a:ln>
-        </p:spPr>
-        <p:style>
-          <a:lnRef idx="2">
-            <a:schemeClr val="accent1"/>
-          </a:lnRef>
-          <a:fillRef idx="0">
-            <a:schemeClr val="accent1"/>
-          </a:fillRef>
-          <a:effectRef idx="1">
-            <a:schemeClr val="accent1"/>
-          </a:effectRef>
-          <a:fontRef idx="minor">
-            <a:schemeClr val="tx1"/>
-          </a:fontRef>
-        </p:style>
-      </p:cxnSp>
-      <p:sp>
-        <p:nvSpPr>
-          <p:cNvPr id="4" name="TextBox 3"/>
-          <p:cNvSpPr txBox="1"/>
-          <p:nvPr/>
-        </p:nvSpPr>
-        <p:spPr>
-          <a:xfrm>
-            <a:off x="548640" y="1280160"/>
-            <a:ext cx="11094415" cy="5120640"/>
-          </a:xfrm>
-          <a:prstGeom prst="rect">
-            <a:avLst/>
-          </a:prstGeom>
-          <a:noFill/>
-        </p:spPr>
-        <p:txBody>
-          <a:bodyPr wrap="square">
-            <a:spAutoFit/>
-          </a:bodyPr>
-          <a:lstStyle/>
-          <a:p>
-            <a:pPr algn="l">
-              <a:spcAft>
-                <a:spcPts val="800"/>
-              </a:spcAft>
-            </a:pPr>
-            <a:r>
-              <a:rPr sz="2200">
-                <a:solidFill>
-                  <a:srgbClr val="101824"/>
-                </a:solidFill>
-                <a:latin typeface="Calibri"/>
-              </a:rPr>
-              <a:t>•  Goal: water visibly falls from the sky and the map's surface gets wet.</a:t>
-            </a:r>
-          </a:p>
-          <a:p>
-            <a:pPr algn="l">
-              <a:spcAft>
-                <a:spcPts val="800"/>
-              </a:spcAft>
-            </a:pPr>
-            <a:r>
-              <a:rPr sz="2200">
-                <a:solidFill>
-                  <a:srgbClr val="101824"/>
-                </a:solidFill>
-                <a:latin typeface="Calibri"/>
-              </a:rPr>
-              <a:t>•  Two components: a new IHazardousWeather (familiar) + a way to add water to map tiles.</a:t>
-            </a:r>
-          </a:p>
-          <a:p>
-            <a:pPr algn="l" lvl="1">
-              <a:spcAft>
-                <a:spcPts val="800"/>
-              </a:spcAft>
-            </a:pPr>
-            <a:r>
-              <a:rPr sz="1800">
-                <a:solidFill>
-                  <a:srgbClr val="556070"/>
-                </a:solidFill>
-                <a:latin typeface="Calibri"/>
-              </a:rPr>
-              <a:t>    –  Hazard plumbing: copy the FloodWeather pattern. Spoof Id, parallel branches in patches.</a:t>
-            </a:r>
-          </a:p>
-          <a:p>
-            <a:pPr algn="l" lvl="1">
-              <a:spcAft>
-                <a:spcPts val="800"/>
-              </a:spcAft>
-            </a:pPr>
-            <a:r>
-              <a:rPr sz="1800">
-                <a:solidFill>
-                  <a:srgbClr val="556070"/>
-                </a:solidFill>
-                <a:latin typeface="Calibri"/>
-              </a:rPr>
-              <a:t>    –  Water-adding mechanic: needs investigation. Candidates worth grepping:</a:t>
-            </a:r>
-          </a:p>
-          <a:p>
-            <a:pPr algn="l" lvl="2">
-              <a:spcAft>
-                <a:spcPts val="800"/>
-              </a:spcAft>
-            </a:pPr>
-            <a:r>
-              <a:rPr sz="1800">
-                <a:solidFill>
-                  <a:srgbClr val="556070"/>
-                </a:solidFill>
-                <a:latin typeface="Calibri"/>
-              </a:rPr>
-              <a:t>        –  WaterAdditionService or similar — anything callable per-tile.</a:t>
-            </a:r>
-          </a:p>
-          <a:p>
-            <a:pPr algn="l" lvl="2">
-              <a:spcAft>
-                <a:spcPts val="800"/>
-              </a:spcAft>
-            </a:pPr>
-            <a:r>
-              <a:rPr sz="1800">
-                <a:solidFill>
-                  <a:srgbClr val="556070"/>
-                </a:solidFill>
-                <a:latin typeface="Calibri"/>
-              </a:rPr>
-              <a:t>        –  Decomp WaterSystem already for SimulateContamination — grep for AddWater, AddDepth, etc.</a:t>
-            </a:r>
-          </a:p>
-          <a:p>
-            <a:pPr algn="l" lvl="2">
-              <a:spcAft>
-                <a:spcPts val="800"/>
-              </a:spcAft>
-            </a:pPr>
-            <a:r>
-              <a:rPr sz="1800">
-                <a:solidFill>
-                  <a:srgbClr val="556070"/>
-                </a:solidFill>
-                <a:latin typeface="Calibri"/>
-              </a:rPr>
-              <a:t>        –  Particle / visual layer: probably orthogonal. Game already has a rain shader for badtide.</a:t>
-            </a:r>
-          </a:p>
-          <a:p>
-            <a:pPr algn="l">
-              <a:spcAft>
-                <a:spcPts val="800"/>
-              </a:spcAft>
-            </a:pPr>
-            <a:r>
-              <a:rPr sz="2200">
-                <a:solidFill>
-                  <a:srgbClr val="101824"/>
-                </a:solidFill>
-                <a:latin typeface="Calibri"/>
-              </a:rPr>
-              <a:t>•  Risk: if water-adding isn't exposed, we're back in Harmony-cascade territory.</a:t>
-            </a:r>
-          </a:p>
-        </p:txBody>
-      </p:sp>
-      <p:sp>
-        <p:nvSpPr>
-          <p:cNvPr id="5" name="TextBox 4"/>
-          <p:cNvSpPr txBox="1"/>
-          <p:nvPr/>
-        </p:nvSpPr>
-        <p:spPr>
-          <a:xfrm>
-            <a:off x="548640" y="6492240"/>
-            <a:ext cx="11094415" cy="320040"/>
-          </a:xfrm>
-          <a:prstGeom prst="rect">
-            <a:avLst/>
-          </a:prstGeom>
-          <a:noFill/>
-        </p:spPr>
-        <p:txBody>
-          <a:bodyPr wrap="square" anchor="t">
-            <a:spAutoFit/>
-          </a:bodyPr>
-          <a:lstStyle/>
-          <a:p>
-            <a:pPr algn="r"/>
-            <a:r>
-              <a:rPr sz="1000" b="0">
-                <a:solidFill>
-                  <a:srgbClr val="556070"/>
-                </a:solidFill>
-                <a:latin typeface="Calibri"/>
-              </a:rPr>
-              <a:t>Mod #4: Rainy Season (future)   ·   37 / 38</a:t>
-            </a:r>
-          </a:p>
-        </p:txBody>
-      </p:sp>
-    </p:spTree>
-  </p:cSld>
-  <p:clrMapOvr>
-    <a:masterClrMapping/>
-  </p:clrMapOvr>
-</p:sld>
-</file>
-
-<file path=ppt/slides/slide38.xml><?xml version="1.0" encoding="utf-8"?>
 <p:sld xmlns:a="http://schemas.openxmlformats.org/drawingml/2006/main" xmlns:p="http://schemas.openxmlformats.org/presentationml/2006/main" xmlns:r="http://schemas.openxmlformats.org/officeDocument/2006/relationships">
   <p:cSld>
     <p:bg>
@@ -16808,7 +16461,7 @@
                 </a:solidFill>
                 <a:latin typeface="Calibri"/>
               </a:rPr>
-              <a:t>Opening   ·   4 / 38</a:t>
+              <a:t>Opening   ·   4 / 37</a:t>
             </a:r>
           </a:p>
         </p:txBody>
@@ -17042,7 +16695,7 @@
                 </a:solidFill>
                 <a:latin typeface="Calibri"/>
               </a:rPr>
-              <a:t>About Timberborn   ·   5 / 38</a:t>
+              <a:t>About Timberborn   ·   5 / 37</a:t>
             </a:r>
           </a:p>
         </p:txBody>
@@ -17276,7 +16929,7 @@
                 </a:solidFill>
                 <a:latin typeface="Calibri"/>
               </a:rPr>
-              <a:t>About Timberborn   ·   6 / 38</a:t>
+              <a:t>About Timberborn   ·   6 / 37</a:t>
             </a:r>
           </a:p>
         </p:txBody>
@@ -17675,7 +17328,7 @@
                 </a:solidFill>
                 <a:latin typeface="Calibri"/>
               </a:rPr>
-              <a:t>About Timberborn   ·   7 / 38</a:t>
+              <a:t>About Timberborn   ·   7 / 37</a:t>
             </a:r>
           </a:p>
         </p:txBody>
@@ -17957,7 +17610,7 @@
                 </a:solidFill>
                 <a:latin typeface="Calibri"/>
               </a:rPr>
-              <a:t>About Timberborn   ·   8 / 38</a:t>
+              <a:t>About Timberborn   ·   8 / 37</a:t>
             </a:r>
           </a:p>
         </p:txBody>
@@ -18207,7 +17860,7 @@
                 </a:solidFill>
                 <a:latin typeface="Calibri"/>
               </a:rPr>
-              <a:t>Mod #1: Quadruple Platform   ·   9 / 38</a:t>
+              <a:t>Mod #1: Quadruple Platform   ·   9 / 37</a:t>
             </a:r>
           </a:p>
         </p:txBody>

</xml_diff>